<commit_message>
learned promisses as a alt option to callback function
</commit_message>
<xml_diff>
--- a/ROADMAP/roadmap js.pptx
+++ b/ROADMAP/roadmap js.pptx
@@ -269,7 +269,7 @@
           <a:p>
             <a:fld id="{3757B9D6-B1DD-42FC-8CF6-CEEED335747B}" type="datetimeFigureOut">
               <a:rPr lang="en-IN" smtClean="0"/>
-              <a:t>02-01-2026</a:t>
+              <a:t>04-01-2026</a:t>
             </a:fld>
             <a:endParaRPr lang="en-IN"/>
           </a:p>
@@ -469,7 +469,7 @@
           <a:p>
             <a:fld id="{3757B9D6-B1DD-42FC-8CF6-CEEED335747B}" type="datetimeFigureOut">
               <a:rPr lang="en-IN" smtClean="0"/>
-              <a:t>02-01-2026</a:t>
+              <a:t>04-01-2026</a:t>
             </a:fld>
             <a:endParaRPr lang="en-IN"/>
           </a:p>
@@ -679,7 +679,7 @@
           <a:p>
             <a:fld id="{3757B9D6-B1DD-42FC-8CF6-CEEED335747B}" type="datetimeFigureOut">
               <a:rPr lang="en-IN" smtClean="0"/>
-              <a:t>02-01-2026</a:t>
+              <a:t>04-01-2026</a:t>
             </a:fld>
             <a:endParaRPr lang="en-IN"/>
           </a:p>
@@ -879,7 +879,7 @@
           <a:p>
             <a:fld id="{3757B9D6-B1DD-42FC-8CF6-CEEED335747B}" type="datetimeFigureOut">
               <a:rPr lang="en-IN" smtClean="0"/>
-              <a:t>02-01-2026</a:t>
+              <a:t>04-01-2026</a:t>
             </a:fld>
             <a:endParaRPr lang="en-IN"/>
           </a:p>
@@ -1155,7 +1155,7 @@
           <a:p>
             <a:fld id="{3757B9D6-B1DD-42FC-8CF6-CEEED335747B}" type="datetimeFigureOut">
               <a:rPr lang="en-IN" smtClean="0"/>
-              <a:t>02-01-2026</a:t>
+              <a:t>04-01-2026</a:t>
             </a:fld>
             <a:endParaRPr lang="en-IN"/>
           </a:p>
@@ -1423,7 +1423,7 @@
           <a:p>
             <a:fld id="{3757B9D6-B1DD-42FC-8CF6-CEEED335747B}" type="datetimeFigureOut">
               <a:rPr lang="en-IN" smtClean="0"/>
-              <a:t>02-01-2026</a:t>
+              <a:t>04-01-2026</a:t>
             </a:fld>
             <a:endParaRPr lang="en-IN"/>
           </a:p>
@@ -1838,7 +1838,7 @@
           <a:p>
             <a:fld id="{3757B9D6-B1DD-42FC-8CF6-CEEED335747B}" type="datetimeFigureOut">
               <a:rPr lang="en-IN" smtClean="0"/>
-              <a:t>02-01-2026</a:t>
+              <a:t>04-01-2026</a:t>
             </a:fld>
             <a:endParaRPr lang="en-IN"/>
           </a:p>
@@ -1980,7 +1980,7 @@
           <a:p>
             <a:fld id="{3757B9D6-B1DD-42FC-8CF6-CEEED335747B}" type="datetimeFigureOut">
               <a:rPr lang="en-IN" smtClean="0"/>
-              <a:t>02-01-2026</a:t>
+              <a:t>04-01-2026</a:t>
             </a:fld>
             <a:endParaRPr lang="en-IN"/>
           </a:p>
@@ -2093,7 +2093,7 @@
           <a:p>
             <a:fld id="{3757B9D6-B1DD-42FC-8CF6-CEEED335747B}" type="datetimeFigureOut">
               <a:rPr lang="en-IN" smtClean="0"/>
-              <a:t>02-01-2026</a:t>
+              <a:t>04-01-2026</a:t>
             </a:fld>
             <a:endParaRPr lang="en-IN"/>
           </a:p>
@@ -2406,7 +2406,7 @@
           <a:p>
             <a:fld id="{3757B9D6-B1DD-42FC-8CF6-CEEED335747B}" type="datetimeFigureOut">
               <a:rPr lang="en-IN" smtClean="0"/>
-              <a:t>02-01-2026</a:t>
+              <a:t>04-01-2026</a:t>
             </a:fld>
             <a:endParaRPr lang="en-IN"/>
           </a:p>
@@ -2695,7 +2695,7 @@
           <a:p>
             <a:fld id="{3757B9D6-B1DD-42FC-8CF6-CEEED335747B}" type="datetimeFigureOut">
               <a:rPr lang="en-IN" smtClean="0"/>
-              <a:t>02-01-2026</a:t>
+              <a:t>04-01-2026</a:t>
             </a:fld>
             <a:endParaRPr lang="en-IN"/>
           </a:p>
@@ -2938,7 +2938,7 @@
           <a:p>
             <a:fld id="{3757B9D6-B1DD-42FC-8CF6-CEEED335747B}" type="datetimeFigureOut">
               <a:rPr lang="en-IN" smtClean="0"/>
-              <a:t>02-01-2026</a:t>
+              <a:t>04-01-2026</a:t>
             </a:fld>
             <a:endParaRPr lang="en-IN"/>
           </a:p>
@@ -7369,7 +7369,7 @@
             <p:ph idx="1"/>
             <p:extLst>
               <p:ext uri="{D42A27DB-BD31-4B8C-83A1-F6EECF244321}">
-                <p14:modId xmlns:p14="http://schemas.microsoft.com/office/powerpoint/2010/main" val="3295452415"/>
+                <p14:modId xmlns:p14="http://schemas.microsoft.com/office/powerpoint/2010/main" val="1551223675"/>
               </p:ext>
             </p:extLst>
           </p:nvPr>
@@ -8944,12 +8944,12 @@
                     <a:p>
                       <a:pPr algn="l" fontAlgn="b"/>
                       <a:r>
-                        <a:rPr lang="en-IN" sz="1400" u="none" strike="noStrike">
-                          <a:effectLst/>
-                        </a:rPr>
-                        <a:t> </a:t>
-                      </a:r>
-                      <a:endParaRPr lang="en-IN" sz="1400" b="0" i="0" u="none" strike="noStrike">
+                        <a:rPr lang="en-IN" sz="1400" u="none" strike="noStrike" dirty="0">
+                          <a:effectLst/>
+                        </a:rPr>
+                        <a:t>              DONE</a:t>
+                      </a:r>
+                      <a:endParaRPr lang="en-IN" sz="1400" b="0" i="0" u="none" strike="noStrike" dirty="0">
                         <a:solidFill>
                           <a:srgbClr val="000000"/>
                         </a:solidFill>
@@ -9096,12 +9096,12 @@
                     <a:p>
                       <a:pPr algn="ctr" fontAlgn="b"/>
                       <a:r>
-                        <a:rPr lang="en-IN" sz="1400" u="none" strike="noStrike">
+                        <a:rPr lang="en-IN" sz="1400" u="none" strike="noStrike" dirty="0">
                           <a:effectLst/>
                         </a:rPr>
                         <a:t> </a:t>
                       </a:r>
-                      <a:endParaRPr lang="en-IN" sz="1400" b="0" i="0" u="none" strike="noStrike">
+                      <a:endParaRPr lang="en-IN" sz="1400" b="0" i="0" u="none" strike="noStrike" dirty="0">
                         <a:solidFill>
                           <a:srgbClr val="000000"/>
                         </a:solidFill>
@@ -9298,12 +9298,12 @@
                     <a:p>
                       <a:pPr algn="ctr" fontAlgn="b"/>
                       <a:r>
-                        <a:rPr lang="en-IN" sz="1400" u="none" strike="noStrike">
+                        <a:rPr lang="en-IN" sz="1400" u="none" strike="noStrike" dirty="0">
                           <a:effectLst/>
                         </a:rPr>
                         <a:t> </a:t>
                       </a:r>
-                      <a:endParaRPr lang="en-IN" sz="1400" b="0" i="0" u="none" strike="noStrike">
+                      <a:endParaRPr lang="en-IN" sz="1400" b="0" i="0" u="none" strike="noStrike" dirty="0">
                         <a:solidFill>
                           <a:srgbClr val="000000"/>
                         </a:solidFill>

</xml_diff>